<commit_message>
Update Task 4 PPT: Include EDA graphs
</commit_message>
<xml_diff>
--- a/ahmed essam tasks/task4/Task4_Presentation.pptx
+++ b/ahmed essam tasks/task4/Task4_Presentation.pptx
@@ -3134,12 +3134,7 @@
           <a:lstStyle/>
           <a:p>
             <a:r>
-              <a:t>Time-Series Exploratory Data Analysis (2022-2023)</a:t>
-            </a:r>
-          </a:p>
-          <a:p>
-            <a:r>
-              <a:t>Task 4 Presentation</a:t>
+              <a:t>Time-Series Exploratory Data Analysis (2022-2023)\nTask 4 Presentation</a:t>
             </a:r>
           </a:p>
         </p:txBody>
@@ -3361,15 +3356,7 @@
               <a:defRPr sz="2000"/>
             </a:pPr>
             <a:r>
-              <a:t>Temperature (Mean, Min, Max), Precipitation, Humidity,</a:t>
-            </a:r>
-          </a:p>
-          <a:p>
-            <a:pPr lvl="1">
-              <a:defRPr sz="2000"/>
-            </a:pPr>
-            <a:r>
-              <a:t>Wind Speed, and Cloud Cover.</a:t>
+              <a:t>Temperature (Mean, Min, Max), Precipitation, Humidity, Wind Speed, Cloud Cover.</a:t>
             </a:r>
           </a:p>
           <a:p>
@@ -3504,7 +3491,7 @@
               <a:defRPr sz="2000"/>
             </a:pPr>
             <a:r>
-              <a:t>Justification: Weather shifts smoothly; interpolation preserves natural patterns better than dropping rows.</a:t>
+              <a:t>Justification: Weather shifts smoothly; interpolation preserves natural patterns.</a:t>
             </a:r>
           </a:p>
           <a:p>
@@ -3717,76 +3704,56 @@
             <p:ph idx="1"/>
           </p:nvPr>
         </p:nvSpPr>
-        <p:spPr/>
+        <p:spPr>
+          <a:xfrm>
+            <a:ext cx="0" cy="2286000"/>
+          </a:xfrm>
+        </p:spPr>
         <p:txBody>
           <a:bodyPr/>
           <a:lstStyle/>
           <a:p>
             <a:pPr>
-              <a:defRPr sz="2400"/>
-            </a:pPr>
-            <a:r>
-              <a:t>Line Plots:</a:t>
-            </a:r>
-          </a:p>
-          <a:p>
-            <a:pPr lvl="1">
-              <a:defRPr sz="2000"/>
-            </a:pPr>
-            <a:r>
-              <a:t>Displayed full 2-year trajectory for each variable.</a:t>
+              <a:defRPr sz="1800"/>
+            </a:pPr>
+            <a:r>
+              <a:t>30-day rolling means smooth out daily noise.</a:t>
             </a:r>
           </a:p>
           <a:p>
             <a:pPr>
-              <a:defRPr sz="2400"/>
-            </a:pPr>
-            <a:r>
-              <a:t>Rolling Means:</a:t>
-            </a:r>
-          </a:p>
-          <a:p>
-            <a:pPr lvl="1">
-              <a:defRPr sz="2000"/>
-            </a:pPr>
-            <a:r>
-              <a:t>Applied 7-day and 30-day rolling means to smooth daily noise.</a:t>
-            </a:r>
-          </a:p>
-          <a:p>
-            <a:pPr lvl="1">
-              <a:defRPr sz="2000"/>
-            </a:pPr>
-            <a:r>
-              <a:t>30-day trend perfectly highlights the macro seasonal cycle.</a:t>
-            </a:r>
-          </a:p>
-          <a:p>
-            <a:pPr>
-              <a:defRPr sz="2400"/>
-            </a:pPr>
-            <a:r>
-              <a:t>Observations:</a:t>
-            </a:r>
-          </a:p>
-          <a:p>
-            <a:pPr lvl="1">
-              <a:defRPr sz="2000"/>
-            </a:pPr>
-            <a:r>
-              <a:t>Clear, repeating wave pattern for temperature.</a:t>
-            </a:r>
-          </a:p>
-          <a:p>
-            <a:pPr lvl="1">
-              <a:defRPr sz="2000"/>
-            </a:pPr>
-            <a:r>
-              <a:t>Precipitation spikes sporadically, almost exclusively in winter.</a:t>
-            </a:r>
-          </a:p>
-        </p:txBody>
-      </p:sp>
+              <a:defRPr sz="1800"/>
+            </a:pPr>
+            <a:r>
+              <a:t>Clear repeating wave for temperature. Precipitation spikes exclusively in winter.</a:t>
+            </a:r>
+          </a:p>
+        </p:txBody>
+      </p:sp>
+      <p:pic>
+        <p:nvPicPr>
+          <p:cNvPr id="4" name="Picture 3" descr="temporal_trends.png"/>
+          <p:cNvPicPr>
+            <a:picLocks noChangeAspect="1"/>
+          </p:cNvPicPr>
+          <p:nvPr/>
+        </p:nvPicPr>
+        <p:blipFill>
+          <a:blip r:embed="rId2"/>
+          <a:stretch>
+            <a:fillRect/>
+          </a:stretch>
+        </p:blipFill>
+        <p:spPr>
+          <a:xfrm>
+            <a:off x="914400" y="3657600"/>
+            <a:ext cx="7315200" cy="4572000"/>
+          </a:xfrm>
+          <a:prstGeom prst="rect">
+            <a:avLst/>
+          </a:prstGeom>
+        </p:spPr>
+      </p:pic>
     </p:spTree>
   </p:cSld>
   <p:clrMapOvr>
@@ -3836,84 +3803,56 @@
             <p:ph idx="1"/>
           </p:nvPr>
         </p:nvSpPr>
-        <p:spPr/>
+        <p:spPr>
+          <a:xfrm>
+            <a:ext cx="0" cy="2286000"/>
+          </a:xfrm>
+        </p:spPr>
         <p:txBody>
           <a:bodyPr/>
           <a:lstStyle/>
           <a:p>
             <a:pPr>
-              <a:defRPr sz="2400"/>
-            </a:pPr>
-            <a:r>
-              <a:t>Monthly Boxplots:</a:t>
-            </a:r>
-          </a:p>
-          <a:p>
-            <a:pPr lvl="1">
-              <a:defRPr sz="2000"/>
-            </a:pPr>
-            <a:r>
-              <a:t>Grouped data by month to observe the seasonal cycle.</a:t>
+              <a:defRPr sz="1800"/>
+            </a:pPr>
+            <a:r>
+              <a:t>Temperature peaks in July/Aug and dips in Jan/Feb.</a:t>
             </a:r>
           </a:p>
           <a:p>
             <a:pPr>
-              <a:defRPr sz="2400"/>
-            </a:pPr>
-            <a:r>
-              <a:t>Temperature:</a:t>
-            </a:r>
-          </a:p>
-          <a:p>
-            <a:pPr lvl="1">
-              <a:defRPr sz="2000"/>
-            </a:pPr>
-            <a:r>
-              <a:t>Peaks in July/August (Summer).</a:t>
-            </a:r>
-          </a:p>
-          <a:p>
-            <a:pPr lvl="1">
-              <a:defRPr sz="2000"/>
-            </a:pPr>
-            <a:r>
-              <a:t>Dips in January/February (Winter).</a:t>
-            </a:r>
-          </a:p>
-          <a:p>
-            <a:pPr lvl="1">
-              <a:defRPr sz="2000"/>
-            </a:pPr>
-            <a:r>
-              <a:t>High variance in transition months (Spring/Autumn).</a:t>
-            </a:r>
-          </a:p>
-          <a:p>
-            <a:pPr>
-              <a:defRPr sz="2400"/>
-            </a:pPr>
-            <a:r>
-              <a:t>Precipitation:</a:t>
-            </a:r>
-          </a:p>
-          <a:p>
-            <a:pPr lvl="1">
-              <a:defRPr sz="2000"/>
-            </a:pPr>
-            <a:r>
-              <a:t>Confined mostly to November - March.</a:t>
-            </a:r>
-          </a:p>
-          <a:p>
-            <a:pPr lvl="1">
-              <a:defRPr sz="2000"/>
-            </a:pPr>
-            <a:r>
-              <a:t>Summers (June - September) are completely dry.</a:t>
-            </a:r>
-          </a:p>
-        </p:txBody>
-      </p:sp>
+              <a:defRPr sz="1800"/>
+            </a:pPr>
+            <a:r>
+              <a:t>Rain is confined almost entirely to Nov-Mar (Summers are completely dry).</a:t>
+            </a:r>
+          </a:p>
+        </p:txBody>
+      </p:sp>
+      <p:pic>
+        <p:nvPicPr>
+          <p:cNvPr id="4" name="Picture 3" descr="seasonality.png"/>
+          <p:cNvPicPr>
+            <a:picLocks noChangeAspect="1"/>
+          </p:cNvPicPr>
+          <p:nvPr/>
+        </p:nvPicPr>
+        <p:blipFill>
+          <a:blip r:embed="rId2"/>
+          <a:stretch>
+            <a:fillRect/>
+          </a:stretch>
+        </p:blipFill>
+        <p:spPr>
+          <a:xfrm>
+            <a:off x="914400" y="3657600"/>
+            <a:ext cx="7315200" cy="2438400"/>
+          </a:xfrm>
+          <a:prstGeom prst="rect">
+            <a:avLst/>
+          </a:prstGeom>
+        </p:spPr>
+      </p:pic>
     </p:spTree>
   </p:cSld>
   <p:clrMapOvr>
@@ -3963,76 +3902,56 @@
             <p:ph idx="1"/>
           </p:nvPr>
         </p:nvSpPr>
-        <p:spPr/>
+        <p:spPr>
+          <a:xfrm>
+            <a:ext cx="0" cy="2286000"/>
+          </a:xfrm>
+        </p:spPr>
         <p:txBody>
           <a:bodyPr/>
           <a:lstStyle/>
           <a:p>
             <a:pPr>
-              <a:defRPr sz="2400"/>
-            </a:pPr>
-            <a:r>
-              <a:t>STL Decomposition (Seasonal-Trend using Loess):</a:t>
-            </a:r>
-          </a:p>
-          <a:p>
-            <a:pPr lvl="1">
-              <a:defRPr sz="2000"/>
-            </a:pPr>
-            <a:r>
-              <a:t>Separated Temperature and Precipitation into 3 components.</a:t>
+              <a:defRPr sz="1800"/>
+            </a:pPr>
+            <a:r>
+              <a:t>Trend component is flat (stable climate over the 2 years).</a:t>
             </a:r>
           </a:p>
           <a:p>
             <a:pPr>
-              <a:defRPr sz="2400"/>
-            </a:pPr>
-            <a:r>
-              <a:t>1. Trend Component:</a:t>
-            </a:r>
-          </a:p>
-          <a:p>
-            <a:pPr lvl="1">
-              <a:defRPr sz="2000"/>
-            </a:pPr>
-            <a:r>
-              <a:t>Temperature trend is relatively flat (stable over 2 years).</a:t>
-            </a:r>
-          </a:p>
-          <a:p>
-            <a:pPr>
-              <a:defRPr sz="2400"/>
-            </a:pPr>
-            <a:r>
-              <a:t>2. Seasonal Component:</a:t>
-            </a:r>
-          </a:p>
-          <a:p>
-            <a:pPr lvl="1">
-              <a:defRPr sz="2000"/>
-            </a:pPr>
-            <a:r>
-              <a:t>Very strong and regular annual cycle for temperature.</a:t>
-            </a:r>
-          </a:p>
-          <a:p>
-            <a:pPr>
-              <a:defRPr sz="2400"/>
-            </a:pPr>
-            <a:r>
-              <a:t>3. Residual (Noise):</a:t>
-            </a:r>
-          </a:p>
-          <a:p>
-            <a:pPr lvl="1">
-              <a:defRPr sz="2000"/>
-            </a:pPr>
-            <a:r>
-              <a:t>Day-to-day noise is small compared to the seasonal swing.</a:t>
-            </a:r>
-          </a:p>
-        </p:txBody>
-      </p:sp>
+              <a:defRPr sz="1800"/>
+            </a:pPr>
+            <a:r>
+              <a:t>Seasonal component dominates the signal perfectly.</a:t>
+            </a:r>
+          </a:p>
+        </p:txBody>
+      </p:sp>
+      <p:pic>
+        <p:nvPicPr>
+          <p:cNvPr id="4" name="Picture 3" descr="stl_decomposition.png"/>
+          <p:cNvPicPr>
+            <a:picLocks noChangeAspect="1"/>
+          </p:cNvPicPr>
+          <p:nvPr/>
+        </p:nvPicPr>
+        <p:blipFill>
+          <a:blip r:embed="rId2"/>
+          <a:stretch>
+            <a:fillRect/>
+          </a:stretch>
+        </p:blipFill>
+        <p:spPr>
+          <a:xfrm>
+            <a:off x="914400" y="3657600"/>
+            <a:ext cx="7315200" cy="5486400"/>
+          </a:xfrm>
+          <a:prstGeom prst="rect">
+            <a:avLst/>
+          </a:prstGeom>
+        </p:spPr>
+      </p:pic>
     </p:spTree>
   </p:cSld>
   <p:clrMapOvr>

</xml_diff>

<commit_message>
Fix Task 4 PPT: properly adjusted image layout
</commit_message>
<xml_diff>
--- a/ahmed essam tasks/task4/Task4_Presentation.pptx
+++ b/ahmed essam tasks/task4/Task4_Presentation.pptx
@@ -3134,7 +3134,12 @@
           <a:lstStyle/>
           <a:p>
             <a:r>
-              <a:t>Time-Series Exploratory Data Analysis (2022-2023)\nTask 4 Presentation</a:t>
+              <a:t>Time-Series Exploratory Data Analysis (2022-2023)</a:t>
+            </a:r>
+          </a:p>
+          <a:p>
+            <a:r>
+              <a:t>Task 4 Presentation</a:t>
             </a:r>
           </a:p>
         </p:txBody>
@@ -3194,31 +3199,39 @@
           <a:lstStyle/>
           <a:p>
             <a:pPr>
-              <a:defRPr sz="2400"/>
-            </a:pPr>
-            <a:r>
-              <a:t>Summary of Findings:</a:t>
+              <a:defRPr sz="1800"/>
+            </a:pPr>
+            <a:r>
+              <a:t>Key Findings:</a:t>
             </a:r>
           </a:p>
           <a:p>
             <a:pPr lvl="1">
-              <a:defRPr sz="2000"/>
-            </a:pPr>
-            <a:r>
-              <a:t>Cairo's weather is highly predictable on a seasonal basis.</a:t>
+              <a:defRPr sz="1500"/>
+            </a:pPr>
+            <a:r>
+              <a:t>Cairo's weather follows a strong, predictable annual seasonal cycle.</a:t>
             </a:r>
           </a:p>
           <a:p>
             <a:pPr lvl="1">
-              <a:defRPr sz="2000"/>
-            </a:pPr>
-            <a:r>
-              <a:t>The NASA POWER API provided a clean, robust dataset.</a:t>
+              <a:defRPr sz="1500"/>
+            </a:pPr>
+            <a:r>
+              <a:t>Precipitation is sparse and event-driven (arid desert climate).</a:t>
+            </a:r>
+          </a:p>
+          <a:p>
+            <a:pPr lvl="1">
+              <a:defRPr sz="1500"/>
+            </a:pPr>
+            <a:r>
+              <a:t>Data quality from NASA POWER was excellent with no anomalies.</a:t>
             </a:r>
           </a:p>
           <a:p>
             <a:pPr>
-              <a:defRPr sz="2400"/>
+              <a:defRPr sz="1800"/>
             </a:pPr>
             <a:r>
               <a:t>Modeling Implications:</a:t>
@@ -3226,23 +3239,23 @@
           </a:p>
           <a:p>
             <a:pPr lvl="1">
-              <a:defRPr sz="2000"/>
-            </a:pPr>
-            <a:r>
-              <a:t>Temperature forecasting should use seasonal models (e.g., SARIMA, Prophet).</a:t>
+              <a:defRPr sz="1500"/>
+            </a:pPr>
+            <a:r>
+              <a:t>Temperature: Use seasonal models (SARIMA, Prophet).</a:t>
             </a:r>
           </a:p>
           <a:p>
             <a:pPr lvl="1">
-              <a:defRPr sz="2000"/>
-            </a:pPr>
-            <a:r>
-              <a:t>Precipitation modeling requires specialized approaches (e.g., zero-inflated models) due to sparsity.</a:t>
+              <a:defRPr sz="1500"/>
+            </a:pPr>
+            <a:r>
+              <a:t>Precipitation: Use zero-inflated or count-based models.</a:t>
             </a:r>
           </a:p>
           <a:p>
             <a:pPr>
-              <a:defRPr sz="2400"/>
+              <a:defRPr sz="1800"/>
             </a:pPr>
             <a:r>
               <a:t>Next Steps:</a:t>
@@ -3250,7 +3263,7 @@
           </a:p>
           <a:p>
             <a:pPr lvl="1">
-              <a:defRPr sz="2000"/>
+              <a:defRPr sz="1500"/>
             </a:pPr>
             <a:r>
               <a:t>Ready for predictive modeling or feature engineering.</a:t>
@@ -3313,7 +3326,7 @@
           <a:lstStyle/>
           <a:p>
             <a:pPr>
-              <a:defRPr sz="2400"/>
+              <a:defRPr sz="1800"/>
             </a:pPr>
             <a:r>
               <a:t>Project Goal:</a:t>
@@ -3321,7 +3334,7 @@
           </a:p>
           <a:p>
             <a:pPr lvl="1">
-              <a:defRPr sz="2000"/>
+              <a:defRPr sz="1500"/>
             </a:pPr>
             <a:r>
               <a:t>Perform robust time-series EDA on weather data.</a:t>
@@ -3329,7 +3342,7 @@
           </a:p>
           <a:p>
             <a:pPr>
-              <a:defRPr sz="2400"/>
+              <a:defRPr sz="1800"/>
             </a:pPr>
             <a:r>
               <a:t>Data Source:</a:t>
@@ -3337,7 +3350,7 @@
           </a:p>
           <a:p>
             <a:pPr lvl="1">
-              <a:defRPr sz="2000"/>
+              <a:defRPr sz="1500"/>
             </a:pPr>
             <a:r>
               <a:t>NASA POWER API (free, reliable, daily temporal resolution).</a:t>
@@ -3345,7 +3358,7 @@
           </a:p>
           <a:p>
             <a:pPr>
-              <a:defRPr sz="2400"/>
+              <a:defRPr sz="1800"/>
             </a:pPr>
             <a:r>
               <a:t>Parameters Collected:</a:t>
@@ -3353,7 +3366,7 @@
           </a:p>
           <a:p>
             <a:pPr lvl="1">
-              <a:defRPr sz="2000"/>
+              <a:defRPr sz="1500"/>
             </a:pPr>
             <a:r>
               <a:t>Temperature (Mean, Min, Max), Precipitation, Humidity, Wind Speed, Cloud Cover.</a:t>
@@ -3361,7 +3374,7 @@
           </a:p>
           <a:p>
             <a:pPr>
-              <a:defRPr sz="2400"/>
+              <a:defRPr sz="1800"/>
             </a:pPr>
             <a:r>
               <a:t>Location &amp; Timeframe:</a:t>
@@ -3369,7 +3382,7 @@
           </a:p>
           <a:p>
             <a:pPr lvl="1">
-              <a:defRPr sz="2000"/>
+              <a:defRPr sz="1500"/>
             </a:pPr>
             <a:r>
               <a:t>Cairo, Egypt (Lat: 30.0444, Lon: 31.2357).</a:t>
@@ -3377,10 +3390,10 @@
           </a:p>
           <a:p>
             <a:pPr lvl="1">
-              <a:defRPr sz="2000"/>
-            </a:pPr>
-            <a:r>
-              <a:t>January 1, 2022 – December 31, 2023 (730 days).</a:t>
+              <a:defRPr sz="1500"/>
+            </a:pPr>
+            <a:r>
+              <a:t>January 1, 2022 to December 31, 2023 (730 days).</a:t>
             </a:r>
           </a:p>
         </p:txBody>
@@ -3440,7 +3453,7 @@
           <a:lstStyle/>
           <a:p>
             <a:pPr>
-              <a:defRPr sz="2400"/>
+              <a:defRPr sz="1800"/>
             </a:pPr>
             <a:r>
               <a:t>Parsing &amp; Indexing:</a:t>
@@ -3448,7 +3461,7 @@
           </a:p>
           <a:p>
             <a:pPr lvl="1">
-              <a:defRPr sz="2000"/>
+              <a:defRPr sz="1500"/>
             </a:pPr>
             <a:r>
               <a:t>Dates parsed and set as the DataFrame index (Daily frequency).</a:t>
@@ -3456,7 +3469,7 @@
           </a:p>
           <a:p>
             <a:pPr>
-              <a:defRPr sz="2400"/>
+              <a:defRPr sz="1800"/>
             </a:pPr>
             <a:r>
               <a:t>Handling Sentinels:</a:t>
@@ -3464,15 +3477,15 @@
           </a:p>
           <a:p>
             <a:pPr lvl="1">
-              <a:defRPr sz="2000"/>
-            </a:pPr>
-            <a:r>
-              <a:t>NASA's missing value code (-999.0) was replaced with NaN.</a:t>
+              <a:defRPr sz="1500"/>
+            </a:pPr>
+            <a:r>
+              <a:t>NASA's missing value code (-999.0) replaced with NaN.</a:t>
             </a:r>
           </a:p>
           <a:p>
             <a:pPr>
-              <a:defRPr sz="2400"/>
+              <a:defRPr sz="1800"/>
             </a:pPr>
             <a:r>
               <a:t>Missing Value Imputation:</a:t>
@@ -3480,23 +3493,23 @@
           </a:p>
           <a:p>
             <a:pPr lvl="1">
-              <a:defRPr sz="2000"/>
-            </a:pPr>
-            <a:r>
-              <a:t>Used Linear Interpolation (limit=3 days).</a:t>
+              <a:defRPr sz="1500"/>
+            </a:pPr>
+            <a:r>
+              <a:t>Linear Interpolation (limit = 3 days).</a:t>
             </a:r>
           </a:p>
           <a:p>
             <a:pPr lvl="1">
-              <a:defRPr sz="2000"/>
-            </a:pPr>
-            <a:r>
-              <a:t>Justification: Weather shifts smoothly; interpolation preserves natural patterns.</a:t>
+              <a:defRPr sz="1500"/>
+            </a:pPr>
+            <a:r>
+              <a:t>Justified: weather changes smoothly day to day.</a:t>
             </a:r>
           </a:p>
           <a:p>
             <a:pPr>
-              <a:defRPr sz="2400"/>
+              <a:defRPr sz="1800"/>
             </a:pPr>
             <a:r>
               <a:t>Validation:</a:t>
@@ -3504,7 +3517,7 @@
           </a:p>
           <a:p>
             <a:pPr lvl="1">
-              <a:defRPr sz="2000"/>
+              <a:defRPr sz="1500"/>
             </a:pPr>
             <a:r>
               <a:t>No missing dates in the 730-day sequence.</a:t>
@@ -3512,10 +3525,10 @@
           </a:p>
           <a:p>
             <a:pPr lvl="1">
-              <a:defRPr sz="2000"/>
-            </a:pPr>
-            <a:r>
-              <a:t>Verified unit consistency (e.g., Temperature in °C).</a:t>
+              <a:defRPr sz="1500"/>
+            </a:pPr>
+            <a:r>
+              <a:t>Units verified (Temperature in C, Rainfall in mm, etc.).</a:t>
             </a:r>
           </a:p>
         </p:txBody>
@@ -3575,82 +3588,66 @@
           <a:lstStyle/>
           <a:p>
             <a:pPr>
-              <a:defRPr sz="2400"/>
-            </a:pPr>
-            <a:r>
-              <a:t>Temperature (°C):</a:t>
+              <a:defRPr sz="1800"/>
+            </a:pPr>
+            <a:r>
+              <a:t>Temperature (C):</a:t>
             </a:r>
           </a:p>
           <a:p>
             <a:pPr lvl="1">
-              <a:defRPr sz="2000"/>
-            </a:pPr>
-            <a:r>
-              <a:t>Mean: ~22.5°C, indicating a generally warm climate.</a:t>
+              <a:defRPr sz="1500"/>
+            </a:pPr>
+            <a:r>
+              <a:t>Mean ~22.5 C  |  Range: ~10 C (Winter) to ~35 C+ (Summer).</a:t>
+            </a:r>
+          </a:p>
+          <a:p>
+            <a:pPr>
+              <a:defRPr sz="1800"/>
+            </a:pPr>
+            <a:r>
+              <a:t>Precipitation (mm/day):</a:t>
             </a:r>
           </a:p>
           <a:p>
             <a:pPr lvl="1">
-              <a:defRPr sz="2000"/>
-            </a:pPr>
-            <a:r>
-              <a:t>Range: From ~10°C (Winter minimums) to ~35°C+ (Summer maximums).</a:t>
+              <a:defRPr sz="1500"/>
+            </a:pPr>
+            <a:r>
+              <a:t>Extremely right-skewed: most days have 0 mm rainfall (arid city).</a:t>
             </a:r>
           </a:p>
           <a:p>
             <a:pPr>
-              <a:defRPr sz="2400"/>
-            </a:pPr>
-            <a:r>
-              <a:t>Precipitation (mm/day):</a:t>
+              <a:defRPr sz="1800"/>
+            </a:pPr>
+            <a:r>
+              <a:t>Humidity:</a:t>
             </a:r>
           </a:p>
           <a:p>
             <a:pPr lvl="1">
-              <a:defRPr sz="2000"/>
-            </a:pPr>
-            <a:r>
-              <a:t>Cairo is highly arid.</a:t>
+              <a:defRPr sz="1500"/>
+            </a:pPr>
+            <a:r>
+              <a:t>Inversely related to temperature: drier in summer, more humid in winter.</a:t>
+            </a:r>
+          </a:p>
+          <a:p>
+            <a:pPr>
+              <a:defRPr sz="1800"/>
+            </a:pPr>
+            <a:r>
+              <a:t>Wind Speed:</a:t>
             </a:r>
           </a:p>
           <a:p>
             <a:pPr lvl="1">
-              <a:defRPr sz="2000"/>
-            </a:pPr>
-            <a:r>
-              <a:t>Most days have 0 mm rainfall.</a:t>
-            </a:r>
-          </a:p>
-          <a:p>
-            <a:pPr lvl="1">
-              <a:defRPr sz="2000"/>
-            </a:pPr>
-            <a:r>
-              <a:t>Extremely right-skewed distribution.</a:t>
-            </a:r>
-          </a:p>
-          <a:p>
-            <a:pPr>
-              <a:defRPr sz="2400"/>
-            </a:pPr>
-            <a:r>
-              <a:t>Distributions:</a:t>
-            </a:r>
-          </a:p>
-          <a:p>
-            <a:pPr lvl="1">
-              <a:defRPr sz="2000"/>
-            </a:pPr>
-            <a:r>
-              <a:t>Temperature follows a wide bimodal/normal distribution.</a:t>
-            </a:r>
-          </a:p>
-          <a:p>
-            <a:pPr lvl="1">
-              <a:defRPr sz="2000"/>
-            </a:pPr>
-            <a:r>
-              <a:t>Wind speed and humidity are moderate but fluctuate.</a:t>
+              <a:defRPr sz="1500"/>
+            </a:pPr>
+            <a:r>
+              <a:t>Stable year-round with no strong seasonal pattern.</a:t>
             </a:r>
           </a:p>
         </p:txBody>
@@ -3675,57 +3672,70 @@
       <p:grpSpPr/>
       <p:sp>
         <p:nvSpPr>
-          <p:cNvPr id="2" name="Title 1"/>
-          <p:cNvSpPr>
-            <a:spLocks noGrp="1"/>
-          </p:cNvSpPr>
-          <p:nvPr>
-            <p:ph type="title"/>
-          </p:nvPr>
-        </p:nvSpPr>
-        <p:spPr/>
-        <p:txBody>
-          <a:bodyPr/>
-          <a:lstStyle/>
-          <a:p>
-            <a:r>
-              <a:t>Temporal Trends</a:t>
-            </a:r>
-          </a:p>
-        </p:txBody>
-      </p:sp>
-      <p:sp>
-        <p:nvSpPr>
-          <p:cNvPr id="3" name="Content Placeholder 2"/>
-          <p:cNvSpPr>
-            <a:spLocks noGrp="1"/>
-          </p:cNvSpPr>
-          <p:nvPr>
-            <p:ph idx="1"/>
-          </p:nvPr>
+          <p:cNvPr id="2" name="TextBox 1"/>
+          <p:cNvSpPr txBox="1"/>
+          <p:nvPr/>
         </p:nvSpPr>
         <p:spPr>
           <a:xfrm>
-            <a:ext cx="0" cy="2286000"/>
+            <a:off x="274320" y="137160"/>
+            <a:ext cx="8595360" cy="731520"/>
           </a:xfrm>
+          <a:prstGeom prst="rect">
+            <a:avLst/>
+          </a:prstGeom>
+          <a:noFill/>
         </p:spPr>
         <p:txBody>
-          <a:bodyPr/>
+          <a:bodyPr wrap="square">
+            <a:spAutoFit/>
+          </a:bodyPr>
+          <a:lstStyle/>
+          <a:p>
+            <a:pPr algn="l">
+              <a:defRPr sz="2400" b="1">
+                <a:solidFill>
+                  <a:srgbClr val="1F497D"/>
+                </a:solidFill>
+              </a:defRPr>
+            </a:pPr>
+            <a:r>
+              <a:t>Temporal Trends</a:t>
+            </a:r>
+          </a:p>
+        </p:txBody>
+      </p:sp>
+      <p:sp>
+        <p:nvSpPr>
+          <p:cNvPr id="3" name="TextBox 2"/>
+          <p:cNvSpPr txBox="1"/>
+          <p:nvPr/>
+        </p:nvSpPr>
+        <p:spPr>
+          <a:xfrm>
+            <a:off x="274320" y="822960"/>
+            <a:ext cx="8595360" cy="411480"/>
+          </a:xfrm>
+          <a:prstGeom prst="rect">
+            <a:avLst/>
+          </a:prstGeom>
+          <a:noFill/>
+        </p:spPr>
+        <p:txBody>
+          <a:bodyPr wrap="none">
+            <a:spAutoFit/>
+          </a:bodyPr>
           <a:lstStyle/>
           <a:p>
             <a:pPr>
-              <a:defRPr sz="1800"/>
-            </a:pPr>
-            <a:r>
-              <a:t>30-day rolling means smooth out daily noise.</a:t>
-            </a:r>
-          </a:p>
-          <a:p>
-            <a:pPr>
-              <a:defRPr sz="1800"/>
-            </a:pPr>
-            <a:r>
-              <a:t>Clear repeating wave for temperature. Precipitation spikes exclusively in winter.</a:t>
+              <a:defRPr sz="1300" i="1">
+                <a:solidFill>
+                  <a:srgbClr val="606060"/>
+                </a:solidFill>
+              </a:defRPr>
+            </a:pPr>
+            <a:r>
+              <a:t>Daily values overlaid with 7-day and 30-day rolling means for temperature and precipitation.</a:t>
             </a:r>
           </a:p>
         </p:txBody>
@@ -3746,8 +3756,8 @@
         </p:blipFill>
         <p:spPr>
           <a:xfrm>
-            <a:off x="914400" y="3657600"/>
-            <a:ext cx="7315200" cy="4572000"/>
+            <a:off x="182880" y="1280160"/>
+            <a:ext cx="8778240" cy="5440680"/>
           </a:xfrm>
           <a:prstGeom prst="rect">
             <a:avLst/>
@@ -3774,57 +3784,70 @@
       <p:grpSpPr/>
       <p:sp>
         <p:nvSpPr>
-          <p:cNvPr id="2" name="Title 1"/>
-          <p:cNvSpPr>
-            <a:spLocks noGrp="1"/>
-          </p:cNvSpPr>
-          <p:nvPr>
-            <p:ph type="title"/>
-          </p:nvPr>
-        </p:nvSpPr>
-        <p:spPr/>
-        <p:txBody>
-          <a:bodyPr/>
-          <a:lstStyle/>
-          <a:p>
-            <a:r>
-              <a:t>Seasonality Patterns</a:t>
-            </a:r>
-          </a:p>
-        </p:txBody>
-      </p:sp>
-      <p:sp>
-        <p:nvSpPr>
-          <p:cNvPr id="3" name="Content Placeholder 2"/>
-          <p:cNvSpPr>
-            <a:spLocks noGrp="1"/>
-          </p:cNvSpPr>
-          <p:nvPr>
-            <p:ph idx="1"/>
-          </p:nvPr>
+          <p:cNvPr id="2" name="TextBox 1"/>
+          <p:cNvSpPr txBox="1"/>
+          <p:nvPr/>
         </p:nvSpPr>
         <p:spPr>
           <a:xfrm>
-            <a:ext cx="0" cy="2286000"/>
+            <a:off x="274320" y="137160"/>
+            <a:ext cx="8595360" cy="731520"/>
           </a:xfrm>
+          <a:prstGeom prst="rect">
+            <a:avLst/>
+          </a:prstGeom>
+          <a:noFill/>
         </p:spPr>
         <p:txBody>
-          <a:bodyPr/>
+          <a:bodyPr wrap="square">
+            <a:spAutoFit/>
+          </a:bodyPr>
+          <a:lstStyle/>
+          <a:p>
+            <a:pPr algn="l">
+              <a:defRPr sz="2400" b="1">
+                <a:solidFill>
+                  <a:srgbClr val="1F497D"/>
+                </a:solidFill>
+              </a:defRPr>
+            </a:pPr>
+            <a:r>
+              <a:t>Seasonality Patterns</a:t>
+            </a:r>
+          </a:p>
+        </p:txBody>
+      </p:sp>
+      <p:sp>
+        <p:nvSpPr>
+          <p:cNvPr id="3" name="TextBox 2"/>
+          <p:cNvSpPr txBox="1"/>
+          <p:nvPr/>
+        </p:nvSpPr>
+        <p:spPr>
+          <a:xfrm>
+            <a:off x="274320" y="822960"/>
+            <a:ext cx="8595360" cy="411480"/>
+          </a:xfrm>
+          <a:prstGeom prst="rect">
+            <a:avLst/>
+          </a:prstGeom>
+          <a:noFill/>
+        </p:spPr>
+        <p:txBody>
+          <a:bodyPr wrap="none">
+            <a:spAutoFit/>
+          </a:bodyPr>
           <a:lstStyle/>
           <a:p>
             <a:pPr>
-              <a:defRPr sz="1800"/>
-            </a:pPr>
-            <a:r>
-              <a:t>Temperature peaks in July/Aug and dips in Jan/Feb.</a:t>
-            </a:r>
-          </a:p>
-          <a:p>
-            <a:pPr>
-              <a:defRPr sz="1800"/>
-            </a:pPr>
-            <a:r>
-              <a:t>Rain is confined almost entirely to Nov-Mar (Summers are completely dry).</a:t>
+              <a:defRPr sz="1300" i="1">
+                <a:solidFill>
+                  <a:srgbClr val="606060"/>
+                </a:solidFill>
+              </a:defRPr>
+            </a:pPr>
+            <a:r>
+              <a:t>Monthly boxplots showing temperature peak in Jul/Aug and precipitation confined to Nov-Mar.</a:t>
             </a:r>
           </a:p>
         </p:txBody>
@@ -3845,8 +3868,8 @@
         </p:blipFill>
         <p:spPr>
           <a:xfrm>
-            <a:off x="914400" y="3657600"/>
-            <a:ext cx="7315200" cy="2438400"/>
+            <a:off x="182880" y="1280160"/>
+            <a:ext cx="8778240" cy="5440680"/>
           </a:xfrm>
           <a:prstGeom prst="rect">
             <a:avLst/>
@@ -3873,57 +3896,70 @@
       <p:grpSpPr/>
       <p:sp>
         <p:nvSpPr>
-          <p:cNvPr id="2" name="Title 1"/>
-          <p:cNvSpPr>
-            <a:spLocks noGrp="1"/>
-          </p:cNvSpPr>
-          <p:nvPr>
-            <p:ph type="title"/>
-          </p:nvPr>
-        </p:nvSpPr>
-        <p:spPr/>
-        <p:txBody>
-          <a:bodyPr/>
-          <a:lstStyle/>
-          <a:p>
-            <a:r>
-              <a:t>Time-Series Decomposition (STL)</a:t>
-            </a:r>
-          </a:p>
-        </p:txBody>
-      </p:sp>
-      <p:sp>
-        <p:nvSpPr>
-          <p:cNvPr id="3" name="Content Placeholder 2"/>
-          <p:cNvSpPr>
-            <a:spLocks noGrp="1"/>
-          </p:cNvSpPr>
-          <p:nvPr>
-            <p:ph idx="1"/>
-          </p:nvPr>
+          <p:cNvPr id="2" name="TextBox 1"/>
+          <p:cNvSpPr txBox="1"/>
+          <p:nvPr/>
         </p:nvSpPr>
         <p:spPr>
           <a:xfrm>
-            <a:ext cx="0" cy="2286000"/>
+            <a:off x="274320" y="137160"/>
+            <a:ext cx="8595360" cy="731520"/>
           </a:xfrm>
+          <a:prstGeom prst="rect">
+            <a:avLst/>
+          </a:prstGeom>
+          <a:noFill/>
         </p:spPr>
         <p:txBody>
-          <a:bodyPr/>
+          <a:bodyPr wrap="square">
+            <a:spAutoFit/>
+          </a:bodyPr>
+          <a:lstStyle/>
+          <a:p>
+            <a:pPr algn="l">
+              <a:defRPr sz="2400" b="1">
+                <a:solidFill>
+                  <a:srgbClr val="1F497D"/>
+                </a:solidFill>
+              </a:defRPr>
+            </a:pPr>
+            <a:r>
+              <a:t>Time-Series Decomposition (STL)</a:t>
+            </a:r>
+          </a:p>
+        </p:txBody>
+      </p:sp>
+      <p:sp>
+        <p:nvSpPr>
+          <p:cNvPr id="3" name="TextBox 2"/>
+          <p:cNvSpPr txBox="1"/>
+          <p:nvPr/>
+        </p:nvSpPr>
+        <p:spPr>
+          <a:xfrm>
+            <a:off x="274320" y="822960"/>
+            <a:ext cx="8595360" cy="411480"/>
+          </a:xfrm>
+          <a:prstGeom prst="rect">
+            <a:avLst/>
+          </a:prstGeom>
+          <a:noFill/>
+        </p:spPr>
+        <p:txBody>
+          <a:bodyPr wrap="none">
+            <a:spAutoFit/>
+          </a:bodyPr>
           <a:lstStyle/>
           <a:p>
             <a:pPr>
-              <a:defRPr sz="1800"/>
-            </a:pPr>
-            <a:r>
-              <a:t>Trend component is flat (stable climate over the 2 years).</a:t>
-            </a:r>
-          </a:p>
-          <a:p>
-            <a:pPr>
-              <a:defRPr sz="1800"/>
-            </a:pPr>
-            <a:r>
-              <a:t>Seasonal component dominates the signal perfectly.</a:t>
+              <a:defRPr sz="1300" i="1">
+                <a:solidFill>
+                  <a:srgbClr val="606060"/>
+                </a:solidFill>
+              </a:defRPr>
+            </a:pPr>
+            <a:r>
+              <a:t>Temperature decomposed into Trend, Seasonal, and Residual components using STL (Loess).</a:t>
             </a:r>
           </a:p>
         </p:txBody>
@@ -3944,8 +3980,8 @@
         </p:blipFill>
         <p:spPr>
           <a:xfrm>
-            <a:off x="914400" y="3657600"/>
-            <a:ext cx="7315200" cy="5486400"/>
+            <a:off x="182880" y="1280160"/>
+            <a:ext cx="8778240" cy="5440680"/>
           </a:xfrm>
           <a:prstGeom prst="rect">
             <a:avLst/>
@@ -4007,7 +4043,7 @@
           <a:lstStyle/>
           <a:p>
             <a:pPr>
-              <a:defRPr sz="2400"/>
+              <a:defRPr sz="1800"/>
             </a:pPr>
             <a:r>
               <a:t>ACF &amp; PACF:</a:t>
@@ -4015,42 +4051,58 @@
           </a:p>
           <a:p>
             <a:pPr lvl="1">
-              <a:defRPr sz="2000"/>
-            </a:pPr>
-            <a:r>
-              <a:t>Temperature ACF: Slow decay, indicating strong seasonality and memory.</a:t>
+              <a:defRPr sz="1500"/>
+            </a:pPr>
+            <a:r>
+              <a:t>Temperature ACF: Slow decay -- strong seasonality and memory.</a:t>
             </a:r>
           </a:p>
           <a:p>
             <a:pPr lvl="1">
-              <a:defRPr sz="2000"/>
-            </a:pPr>
-            <a:r>
-              <a:t>Precipitation ACF: Drops immediately; highly random/event-driven.</a:t>
+              <a:defRPr sz="1500"/>
+            </a:pPr>
+            <a:r>
+              <a:t>Precipitation ACF: Drops immediately -- random and event-driven.</a:t>
             </a:r>
           </a:p>
           <a:p>
             <a:pPr>
-              <a:defRPr sz="2400"/>
-            </a:pPr>
-            <a:r>
-              <a:t>Stationarity (Augmented Dickey-Fuller Test):</a:t>
+              <a:defRPr sz="1800"/>
+            </a:pPr>
+            <a:r>
+              <a:t>Augmented Dickey-Fuller Test:</a:t>
             </a:r>
           </a:p>
           <a:p>
             <a:pPr lvl="1">
-              <a:defRPr sz="2000"/>
-            </a:pPr>
-            <a:r>
-              <a:t>Non-stationary temperature (due to seasonality) requires differencing for ARIMA.</a:t>
+              <a:defRPr sz="1500"/>
+            </a:pPr>
+            <a:r>
+              <a:t>Temperature: Non-stationary (strong seasonal cycle). Needs differencing for ARIMA.</a:t>
             </a:r>
           </a:p>
           <a:p>
             <a:pPr lvl="1">
-              <a:defRPr sz="2000"/>
-            </a:pPr>
-            <a:r>
-              <a:t>Precipitation tests closer to stationary due to constant zero-mean.</a:t>
+              <a:defRPr sz="1500"/>
+            </a:pPr>
+            <a:r>
+              <a:t>Precipitation: Closer to stationary (mean hovers near zero).</a:t>
+            </a:r>
+          </a:p>
+          <a:p>
+            <a:pPr>
+              <a:defRPr sz="1800"/>
+            </a:pPr>
+            <a:r>
+              <a:t>Implication:</a:t>
+            </a:r>
+          </a:p>
+          <a:p>
+            <a:pPr lvl="1">
+              <a:defRPr sz="1500"/>
+            </a:pPr>
+            <a:r>
+              <a:t>Temperature needs SARIMA / seasonal differencing for modeling.</a:t>
             </a:r>
           </a:p>
         </p:txBody>
@@ -4110,7 +4162,7 @@
           <a:lstStyle/>
           <a:p>
             <a:pPr>
-              <a:defRPr sz="2400"/>
+              <a:defRPr sz="1800"/>
             </a:pPr>
             <a:r>
               <a:t>Correlation Matrix:</a:t>
@@ -4118,15 +4170,15 @@
           </a:p>
           <a:p>
             <a:pPr lvl="1">
-              <a:defRPr sz="2000"/>
-            </a:pPr>
-            <a:r>
-              <a:t>Temperature &amp; Humidity: Negatively correlated (hot days are dry).</a:t>
+              <a:defRPr sz="1500"/>
+            </a:pPr>
+            <a:r>
+              <a:t>Temperature &amp; Humidity: Negatively correlated (hot days = dry).</a:t>
             </a:r>
           </a:p>
           <a:p>
             <a:pPr lvl="1">
-              <a:defRPr sz="2000"/>
+              <a:defRPr sz="1500"/>
             </a:pPr>
             <a:r>
               <a:t>Precipitation &amp; Cloud Cover: Positively correlated.</a:t>
@@ -4134,42 +4186,42 @@
           </a:p>
           <a:p>
             <a:pPr>
-              <a:defRPr sz="2400"/>
-            </a:pPr>
-            <a:r>
-              <a:t>Outlier Detection:</a:t>
+              <a:defRPr sz="1800"/>
+            </a:pPr>
+            <a:r>
+              <a:t>Outlier Detection (Rolling Z-Score, window=30, threshold=3 std):</a:t>
             </a:r>
           </a:p>
           <a:p>
             <a:pPr lvl="1">
-              <a:defRPr sz="2000"/>
-            </a:pPr>
-            <a:r>
-              <a:t>Used Rolling Z-Score (30-day window, 3 std deviations).</a:t>
+              <a:defRPr sz="1500"/>
+            </a:pPr>
+            <a:r>
+              <a:t>Seasonal-aware: avoids flagging normal summer highs as outliers.</a:t>
+            </a:r>
+          </a:p>
+          <a:p>
+            <a:pPr>
+              <a:defRPr sz="1800"/>
+            </a:pPr>
+            <a:r>
+              <a:t>Suspicious Values Check:</a:t>
             </a:r>
           </a:p>
           <a:p>
             <a:pPr lvl="1">
-              <a:defRPr sz="2000"/>
-            </a:pPr>
-            <a:r>
-              <a:t>Accounts for seasonality (a 35°C day is normal in Aug, an outlier in Jan).</a:t>
-            </a:r>
-          </a:p>
-          <a:p>
-            <a:pPr>
-              <a:defRPr sz="2400"/>
-            </a:pPr>
-            <a:r>
-              <a:t>Suspicious Values Check:</a:t>
+              <a:defRPr sz="1500"/>
+            </a:pPr>
+            <a:r>
+              <a:t>No negative rainfall, no temperatures outside physical bounds,</a:t>
             </a:r>
           </a:p>
           <a:p>
             <a:pPr lvl="1">
-              <a:defRPr sz="2000"/>
-            </a:pPr>
-            <a:r>
-              <a:t>No physical impossibilities (e.g., negative rainfall or &gt;60°C temp) were found.</a:t>
+              <a:defRPr sz="1500"/>
+            </a:pPr>
+            <a:r>
+              <a:t>No temp_min &gt; temp_max. Data quality confirmed as excellent.</a:t>
             </a:r>
           </a:p>
         </p:txBody>

</xml_diff>